<commit_message>
Module 1: expand to full comprehensive depth (gold-standard template)
- README: full material (CIA triad, threat actors, test types, terminology,
  deep 5-stages, legal, lab setup w/ troubleshooting, Kali tour) — 4→11 pages
- missions.md: graded exercises easy→challenge (4 parts + capstone)
- solutions.md: NEW — full step-by-step solutions to every exercise
- slides.md: expanded 10→13 slides
- dist: rebuilt material + NEW exercises PDF (missions+solutions) + slides

Co-Authored-By: Claude Opus 4.8 <noreply@anthropic.com>
Claude-Session: https://claude.ai/code/session_01Ghjnb4wipnzRi4CSLijMVc
</commit_message>
<xml_diff>
--- a/dist/slides-pptx/01-intro-lab-methodology.pptx
+++ b/dist/slides-pptx/01-intro-lab-methodology.pptx
@@ -15,6 +15,9 @@
     <p:sldId id="263" r:id="rId9"/>
     <p:sldId id="264" r:id="rId10"/>
     <p:sldId id="265" r:id="rId11"/>
+    <p:sldId id="266" r:id="rId12"/>
+    <p:sldId id="267" r:id="rId13"/>
+    <p:sldId id="268" r:id="rId14"/>
   </p:sldIdLst>
   <p:sldSz cx="9144000" cy="5143500" type="screen16x9"/>
   <p:notesSz cx="6858000" cy="9144000"/>
@@ -3173,7 +3176,7 @@
             </a:pPr>
             <a:r>
               <a:rPr/>
-              <a:t>מבוא, מעבדה ו-Kali Linux</a:t>
+              <a:t>מבוא, מעבדה ומתודולוגיה</a:t>
             </a:r>
           </a:p>
         </p:txBody>
@@ -3220,6 +3223,334 @@
             </a:pPr>
             <a:r>
               <a:rPr/>
+              <a:t>הקמת המעבדה</a:t>
+            </a:r>
+          </a:p>
+        </p:txBody>
+      </p:sp>
+      <p:sp>
+        <p:nvSpPr>
+          <p:cNvPr id="3" name="Content Placeholder 2"/>
+          <p:cNvSpPr>
+            <a:spLocks noGrp="1"/>
+          </p:cNvSpPr>
+          <p:nvPr>
+            <p:ph idx="1"/>
+          </p:nvPr>
+        </p:nvSpPr>
+        <p:spPr/>
+        <p:txBody>
+          <a:bodyPr/>
+          <a:lstStyle/>
+          <a:p>
+            <a:pPr lvl="0" algn="r" rtl="1"/>
+            <a:r>
+              <a:rPr b="1"/>
+              <a:t>Hypervisor</a:t>
+            </a:r>
+            <a:r>
+              <a:rPr/>
+              <a:t> — VMware / VirtualBox (חינמי)</a:t>
+            </a:r>
+          </a:p>
+          <a:p>
+            <a:pPr lvl="0" algn="r" rtl="1"/>
+            <a:r>
+              <a:rPr b="1"/>
+              <a:t>תוקף</a:t>
+            </a:r>
+            <a:r>
+              <a:rPr/>
+              <a:t> — Kali Linux · </a:t>
+            </a:r>
+            <a:r>
+              <a:rPr b="1"/>
+              <a:t>מטרות</a:t>
+            </a:r>
+            <a:r>
+              <a:rPr/>
+              <a:t> — Metasploitable, Kioptrix</a:t>
+            </a:r>
+          </a:p>
+          <a:p>
+            <a:pPr lvl="0" algn="r" rtl="1"/>
+            <a:r>
+              <a:rPr/>
+              <a:t>רשת: </a:t>
+            </a:r>
+            <a:r>
+              <a:rPr b="1"/>
+              <a:t>NAT / Host-Only</a:t>
+            </a:r>
+            <a:r>
+              <a:rPr/>
+              <a:t> (לא Bridged!) 🔒</a:t>
+            </a:r>
+          </a:p>
+          <a:p>
+            <a:pPr lvl="0" algn="r" rtl="1"/>
+            <a:r>
+              <a:rPr b="1"/>
+              <a:t>Snapshot</a:t>
+            </a:r>
+            <a:r>
+              <a:rPr/>
+              <a:t> נקי מיד אחרי התקנה</a:t>
+            </a:r>
+          </a:p>
+        </p:txBody>
+      </p:sp>
+    </p:spTree>
+  </p:cSld>
+</p:sld>
+</file>
+
+<file path=ppt/slides/slide11.xml><?xml version="1.0" encoding="utf-8"?>
+<p:sld xmlns:a="http://schemas.openxmlformats.org/drawingml/2006/main" xmlns:r="http://schemas.openxmlformats.org/officeDocument/2006/relationships" xmlns:p="http://schemas.openxmlformats.org/presentationml/2006/main">
+  <p:cSld>
+    <p:spTree>
+      <p:nvGrpSpPr>
+        <p:cNvPr id="1" name=""/>
+        <p:cNvGrpSpPr/>
+        <p:nvPr/>
+      </p:nvGrpSpPr>
+      <p:grpSpPr>
+        <a:xfrm>
+          <a:off x="0" y="0"/>
+          <a:ext cx="0" cy="0"/>
+          <a:chOff x="0" y="0"/>
+          <a:chExt cx="0" cy="0"/>
+        </a:xfrm>
+      </p:grpSpPr>
+      <p:sp>
+        <p:nvSpPr>
+          <p:cNvPr id="2" name="Title 1"/>
+          <p:cNvSpPr>
+            <a:spLocks noGrp="1"/>
+          </p:cNvSpPr>
+          <p:nvPr>
+            <p:ph type="title"/>
+          </p:nvPr>
+        </p:nvSpPr>
+        <p:spPr/>
+        <p:txBody>
+          <a:bodyPr/>
+          <a:lstStyle/>
+          <a:p>
+            <a:pPr marL="0" lvl="0" indent="0" algn="r" rtl="1">
+              <a:buNone/>
+            </a:pPr>
+            <a:r>
+              <a:rPr/>
+              <a:t>Kali Linux — סקירה</a:t>
+            </a:r>
+          </a:p>
+        </p:txBody>
+      </p:sp>
+      <p:sp>
+        <p:nvSpPr>
+          <p:cNvPr id="3" name="Content Placeholder 2"/>
+          <p:cNvSpPr>
+            <a:spLocks noGrp="1"/>
+          </p:cNvSpPr>
+          <p:nvPr>
+            <p:ph idx="1"/>
+          </p:nvPr>
+        </p:nvSpPr>
+        <p:spPr/>
+        <p:txBody>
+          <a:bodyPr/>
+          <a:lstStyle/>
+          <a:p>
+            <a:pPr lvl="0" algn="r" rtl="1"/>
+            <a:r>
+              <a:rPr/>
+              <a:t>הפצת Debian לבדיקות חדירה, 600+ כלים</a:t>
+            </a:r>
+          </a:p>
+          <a:p>
+            <a:pPr lvl="0" algn="r" rtl="1"/>
+            <a:r>
+              <a:rPr/>
+              <a:t>עדכון: </a:t>
+            </a:r>
+            <a:r>
+              <a:rPr>
+                <a:latin typeface="Courier"/>
+              </a:rPr>
+              <a:t>sudo apt update &amp;&amp; sudo apt full-upgrade -y</a:t>
+            </a:r>
+          </a:p>
+          <a:p>
+            <a:pPr lvl="0" algn="r" rtl="1"/>
+            <a:r>
+              <a:rPr b="1"/>
+              <a:t>Terminal</a:t>
+            </a:r>
+            <a:r>
+              <a:rPr/>
+              <a:t> = סביבת העבודה המרכזית</a:t>
+            </a:r>
+          </a:p>
+          <a:p>
+            <a:pPr lvl="0" algn="r" rtl="1"/>
+            <a:r>
+              <a:rPr/>
+              <a:t>wordlists ב-</a:t>
+            </a:r>
+            <a:r>
+              <a:rPr>
+                <a:latin typeface="Courier"/>
+              </a:rPr>
+              <a:t>/usr/share/wordlists</a:t>
+            </a:r>
+            <a:r>
+              <a:rPr/>
+              <a:t> (rockyou)</a:t>
+            </a:r>
+          </a:p>
+        </p:txBody>
+      </p:sp>
+    </p:spTree>
+  </p:cSld>
+</p:sld>
+</file>
+
+<file path=ppt/slides/slide12.xml><?xml version="1.0" encoding="utf-8"?>
+<p:sld xmlns:a="http://schemas.openxmlformats.org/drawingml/2006/main" xmlns:r="http://schemas.openxmlformats.org/officeDocument/2006/relationships" xmlns:p="http://schemas.openxmlformats.org/presentationml/2006/main">
+  <p:cSld>
+    <p:spTree>
+      <p:nvGrpSpPr>
+        <p:cNvPr id="1" name=""/>
+        <p:cNvGrpSpPr/>
+        <p:nvPr/>
+      </p:nvGrpSpPr>
+      <p:grpSpPr>
+        <a:xfrm>
+          <a:off x="0" y="0"/>
+          <a:ext cx="0" cy="0"/>
+          <a:chOff x="0" y="0"/>
+          <a:chExt cx="0" cy="0"/>
+        </a:xfrm>
+      </p:grpSpPr>
+      <p:sp>
+        <p:nvSpPr>
+          <p:cNvPr id="2" name="Title 1"/>
+          <p:cNvSpPr>
+            <a:spLocks noGrp="1"/>
+          </p:cNvSpPr>
+          <p:nvPr>
+            <p:ph type="title"/>
+          </p:nvPr>
+        </p:nvSpPr>
+        <p:spPr/>
+        <p:txBody>
+          <a:bodyPr/>
+          <a:lstStyle/>
+          <a:p>
+            <a:pPr marL="0" lvl="0" indent="0" algn="r" rtl="1">
+              <a:buNone/>
+            </a:pPr>
+            <a:r>
+              <a:rPr/>
+              <a:t>קטגוריות הכלים</a:t>
+            </a:r>
+          </a:p>
+        </p:txBody>
+      </p:sp>
+      <p:sp>
+        <p:nvSpPr>
+          <p:cNvPr id="3" name="Content Placeholder 2"/>
+          <p:cNvSpPr>
+            <a:spLocks noGrp="1"/>
+          </p:cNvSpPr>
+          <p:nvPr>
+            <p:ph idx="1"/>
+          </p:nvPr>
+        </p:nvSpPr>
+        <p:spPr/>
+        <p:txBody>
+          <a:bodyPr/>
+          <a:lstStyle/>
+          <a:p>
+            <a:pPr lvl="0" algn="r" rtl="1"/>
+            <a:r>
+              <a:rPr/>
+              <a:t>Information Gathering — nmap</a:t>
+            </a:r>
+          </a:p>
+          <a:p>
+            <a:pPr lvl="0" algn="r" rtl="1"/>
+            <a:r>
+              <a:rPr/>
+              <a:t>Vulnerability Analysis — nikto, Nessus</a:t>
+            </a:r>
+          </a:p>
+          <a:p>
+            <a:pPr lvl="0" algn="r" rtl="1"/>
+            <a:r>
+              <a:rPr/>
+              <a:t>Web — Burp Suite · Passwords — hydra</a:t>
+            </a:r>
+          </a:p>
+          <a:p>
+            <a:pPr lvl="0" algn="r" rtl="1"/>
+            <a:r>
+              <a:rPr/>
+              <a:t>Exploitation — Metasploit</a:t>
+            </a:r>
+          </a:p>
+          <a:p>
+            <a:pPr lvl="0" algn="r" rtl="1"/>
+            <a:r>
+              <a:rPr/>
+              <a:t>Sniffing — Wireshark · Post-Exp — mimikatz</a:t>
+            </a:r>
+          </a:p>
+        </p:txBody>
+      </p:sp>
+    </p:spTree>
+  </p:cSld>
+</p:sld>
+</file>
+
+<file path=ppt/slides/slide13.xml><?xml version="1.0" encoding="utf-8"?>
+<p:sld xmlns:a="http://schemas.openxmlformats.org/drawingml/2006/main" xmlns:r="http://schemas.openxmlformats.org/officeDocument/2006/relationships" xmlns:p="http://schemas.openxmlformats.org/presentationml/2006/main">
+  <p:cSld>
+    <p:spTree>
+      <p:nvGrpSpPr>
+        <p:cNvPr id="1" name=""/>
+        <p:cNvGrpSpPr/>
+        <p:nvPr/>
+      </p:nvGrpSpPr>
+      <p:grpSpPr>
+        <a:xfrm>
+          <a:off x="0" y="0"/>
+          <a:ext cx="0" cy="0"/>
+          <a:chOff x="0" y="0"/>
+          <a:chExt cx="0" cy="0"/>
+        </a:xfrm>
+      </p:grpSpPr>
+      <p:sp>
+        <p:nvSpPr>
+          <p:cNvPr id="2" name="Title 1"/>
+          <p:cNvSpPr>
+            <a:spLocks noGrp="1"/>
+          </p:cNvSpPr>
+          <p:nvPr>
+            <p:ph type="title"/>
+          </p:nvPr>
+        </p:nvSpPr>
+        <p:spPr/>
+        <p:txBody>
+          <a:bodyPr/>
+          <a:lstStyle/>
+          <a:p>
+            <a:pPr marL="0" lvl="0" indent="0" algn="r" rtl="1">
+              <a:buNone/>
+            </a:pPr>
+            <a:r>
+              <a:rPr/>
               <a:t>סיכום מודול 1</a:t>
             </a:r>
           </a:p>
@@ -3243,39 +3574,63 @@
             <a:pPr lvl="0" algn="r" rtl="1"/>
             <a:r>
               <a:rPr/>
-              <a:t>האקינג אתי = בדיקה מורשית לפני התוקף</a:t>
-            </a:r>
-          </a:p>
-          <a:p>
-            <a:pPr lvl="0" algn="r" rtl="1"/>
-            <a:r>
-              <a:rPr/>
-              <a:t>חמשת השלבים הם הלב של הקורס</a:t>
-            </a:r>
-          </a:p>
-          <a:p>
-            <a:pPr lvl="0" algn="r" rtl="1"/>
-            <a:r>
-              <a:rPr/>
-              <a:t>מעבדה מבודדת = תרגול בטוח</a:t>
-            </a:r>
-          </a:p>
-          <a:p>
-            <a:pPr lvl="0" algn="r" rtl="1"/>
-            <a:r>
-              <a:rPr/>
-              <a:t>Kali = ארגז הכלים המרכזי</a:t>
+              <a:t>האקינג אתי = בדיקה מורשית המגנה על ה-CIA</a:t>
+            </a:r>
+          </a:p>
+          <a:p>
+            <a:pPr lvl="0" algn="r" rtl="1"/>
+            <a:r>
+              <a:rPr/>
+              <a:t>מכירים סוגי האקרים, בדיקות וטרמינולוגיה</a:t>
+            </a:r>
+          </a:p>
+          <a:p>
+            <a:pPr lvl="0" algn="r" rtl="1"/>
+            <a:r>
+              <a:rPr/>
+              <a:t>5 השלבים = הלב של הקורס</a:t>
+            </a:r>
+          </a:p>
+          <a:p>
+            <a:pPr lvl="0" algn="r" rtl="1"/>
+            <a:r>
+              <a:rPr/>
+              <a:t>מעבדה מבודדת + Kali מוכנים</a:t>
             </a:r>
           </a:p>
           <a:p>
             <a:pPr lvl="0" algn="r" rtl="1"/>
             <a:r>
               <a:rPr b="1"/>
-              <a:t>תרגול:</a:t>
-            </a:r>
-            <a:r>
-              <a:rPr/>
-              <a:t> הקם את המעבדה ופתח TryHackMe</a:t>
+              <a:t>תרגילים</a:t>
+            </a:r>
+            <a:r>
+              <a:rPr/>
+              <a:t> → </a:t>
+            </a:r>
+            <a:r>
+              <a:rPr>
+                <a:latin typeface="Courier"/>
+              </a:rPr>
+              <a:t>missions.md</a:t>
+            </a:r>
+            <a:r>
+              <a:rPr/>
+              <a:t> · </a:t>
+            </a:r>
+            <a:r>
+              <a:rPr b="1"/>
+              <a:t>פתרונות</a:t>
+            </a:r>
+            <a:r>
+              <a:rPr/>
+              <a:t> → </a:t>
+            </a:r>
+            <a:r>
+              <a:rPr>
+                <a:latin typeface="Courier"/>
+              </a:rPr>
+              <a:t>solutions.md</a:t>
             </a:r>
           </a:p>
         </p:txBody>
@@ -3345,28 +3700,28 @@
             <a:pPr lvl="0" algn="r" rtl="1"/>
             <a:r>
               <a:rPr/>
-              <a:t>מהו האקינג אתי (Ethical Hacking)?</a:t>
-            </a:r>
-          </a:p>
-          <a:p>
-            <a:pPr lvl="0" algn="r" rtl="1"/>
-            <a:r>
-              <a:rPr/>
-              <a:t>חמשת שלבי התקיפה (Five Stages)</a:t>
-            </a:r>
-          </a:p>
-          <a:p>
-            <a:pPr lvl="0" algn="r" rtl="1"/>
-            <a:r>
-              <a:rPr/>
-              <a:t>הקמת מעבדה וירטואלית (Lab)</a:t>
-            </a:r>
-          </a:p>
-          <a:p>
-            <a:pPr lvl="0" algn="r" rtl="1"/>
-            <a:r>
-              <a:rPr/>
-              <a:t>היכרות עם Kali Linux</a:t>
+              <a:t>מהו האקינג אתי + CIA Triad</a:t>
+            </a:r>
+          </a:p>
+          <a:p>
+            <a:pPr lvl="0" algn="r" rtl="1"/>
+            <a:r>
+              <a:rPr/>
+              <a:t>סוגי האקרים וסוגי בדיקות</a:t>
+            </a:r>
+          </a:p>
+          <a:p>
+            <a:pPr lvl="0" algn="r" rtl="1"/>
+            <a:r>
+              <a:rPr/>
+              <a:t>טרמינולוגיה ומתודולוגיית 5 השלבים</a:t>
+            </a:r>
+          </a:p>
+          <a:p>
+            <a:pPr lvl="0" algn="r" rtl="1"/>
+            <a:r>
+              <a:rPr/>
+              <a:t>הקמת מעבדה + Kali Linux</a:t>
             </a:r>
           </a:p>
         </p:txBody>
@@ -3444,7 +3799,7 @@
             </a:r>
             <a:r>
               <a:rPr/>
-              <a:t> של מערכת למציאת חולשות (Vulnerabilities)</a:t>
+              <a:t> למציאת חולשות לפני התוקף</a:t>
             </a:r>
           </a:p>
           <a:p>
@@ -3528,7 +3883,7 @@
             </a:pPr>
             <a:r>
               <a:rPr/>
-              <a:t>חמשת שלבי ההאקינג האתי</a:t>
+              <a:t>CIA Triad — שלושת עמודי התווך</a:t>
             </a:r>
           </a:p>
         </p:txBody>
@@ -3551,47 +3906,40 @@
             <a:pPr lvl="0" algn="r" rtl="1"/>
             <a:r>
               <a:rPr b="1"/>
-              <a:t>1. איסוף מידע (Reconnaissance)</a:t>
-            </a:r>
-            <a:r>
-              <a:rPr/>
-              <a:t> — פסיבי ואקטיבי</a:t>
+              <a:t>Confidentiality</a:t>
+            </a:r>
+            <a:r>
+              <a:rPr/>
+              <a:t> (סודיות) — רק מורשים רואים</a:t>
             </a:r>
           </a:p>
           <a:p>
             <a:pPr lvl="0" algn="r" rtl="1"/>
             <a:r>
               <a:rPr b="1"/>
-              <a:t>2. סריקה ומיפוי (Scanning &amp; Enumeration)</a:t>
-            </a:r>
-            <a:r>
-              <a:rPr/>
-              <a:t> — פורטים ושירותים</a:t>
+              <a:t>Integrity</a:t>
+            </a:r>
+            <a:r>
+              <a:rPr/>
+              <a:t> (שלמות) — המידע לא שונה</a:t>
             </a:r>
           </a:p>
           <a:p>
             <a:pPr lvl="0" algn="r" rtl="1"/>
             <a:r>
               <a:rPr b="1"/>
-              <a:t>3. השגת גישה (Exploitation)</a:t>
-            </a:r>
-            <a:r>
-              <a:rPr/>
-              <a:t> — ניצול חולשה</a:t>
-            </a:r>
-          </a:p>
-          <a:p>
-            <a:pPr lvl="0" algn="r" rtl="1"/>
-            <a:r>
-              <a:rPr b="1"/>
-              <a:t>4. שמירת גישה (Maintaining Access)</a:t>
-            </a:r>
-          </a:p>
-          <a:p>
-            <a:pPr lvl="0" algn="r" rtl="1"/>
-            <a:r>
-              <a:rPr b="1"/>
-              <a:t>5. טשטוש עקבות (Covering Tracks)</a:t>
+              <a:t>Availability</a:t>
+            </a:r>
+            <a:r>
+              <a:rPr/>
+              <a:t> (זמינות) — המערכת זמינה</a:t>
+            </a:r>
+          </a:p>
+          <a:p>
+            <a:pPr lvl="0" algn="r" rtl="1"/>
+            <a:r>
+              <a:rPr/>
+              <a:t>כל ממצא מסווג לפי העיקרון שנפגע</a:t>
             </a:r>
           </a:p>
         </p:txBody>
@@ -3638,7 +3986,7 @@
             </a:pPr>
             <a:r>
               <a:rPr/>
-              <a:t>הקמת המעבדה (Lab)</a:t>
+              <a:t>סוגי האקרים (Threat Actors)</a:t>
             </a:r>
           </a:p>
         </p:txBody>
@@ -3661,40 +4009,40 @@
             <a:pPr lvl="0" algn="r" rtl="1"/>
             <a:r>
               <a:rPr b="1"/>
-              <a:t>Hypervisor</a:t>
-            </a:r>
-            <a:r>
-              <a:rPr/>
-              <a:t> — VMware Player / VirtualBox (חינמי)</a:t>
+              <a:t>White Hat</a:t>
+            </a:r>
+            <a:r>
+              <a:rPr/>
+              <a:t> — אתי, בהרשאה (זה אנחנו)</a:t>
             </a:r>
           </a:p>
           <a:p>
             <a:pPr lvl="0" algn="r" rtl="1"/>
             <a:r>
               <a:rPr b="1"/>
-              <a:t>מכונת תוקף</a:t>
-            </a:r>
-            <a:r>
-              <a:rPr/>
-              <a:t> — Kali Linux</a:t>
+              <a:t>Black Hat</a:t>
+            </a:r>
+            <a:r>
+              <a:rPr/>
+              <a:t> — זדוני, ללא הרשאה</a:t>
             </a:r>
           </a:p>
           <a:p>
             <a:pPr lvl="0" algn="r" rtl="1"/>
             <a:r>
               <a:rPr b="1"/>
-              <a:t>מכונות מטרה</a:t>
-            </a:r>
-            <a:r>
-              <a:rPr/>
-              <a:t> — Kioptrix, Metasploitable, TryHackMe</a:t>
-            </a:r>
-          </a:p>
-          <a:p>
-            <a:pPr lvl="0" algn="r" rtl="1"/>
-            <a:r>
-              <a:rPr/>
-              <a:t>🔒 רשת מבודדת: Host-Only / NAT</a:t>
+              <a:t>Grey Hat</a:t>
+            </a:r>
+            <a:r>
+              <a:rPr/>
+              <a:t> — ללא הרשאה, ללא זדון</a:t>
+            </a:r>
+          </a:p>
+          <a:p>
+            <a:pPr lvl="0" algn="r" rtl="1"/>
+            <a:r>
+              <a:rPr b="1"/>
+              <a:t>Script Kiddie · Hacktivist · APT · Insider</a:t>
             </a:r>
           </a:p>
         </p:txBody>
@@ -3741,7 +4089,7 @@
             </a:pPr>
             <a:r>
               <a:rPr/>
-              <a:t>התקנת Kali ב-VMware</a:t>
+              <a:t>סוגי בדיקות חדירה</a:t>
             </a:r>
           </a:p>
         </p:txBody>
@@ -3763,62 +4111,41 @@
           <a:p>
             <a:pPr lvl="0" algn="r" rtl="1"/>
             <a:r>
-              <a:rPr/>
-              <a:t>הורדת גרסת ה-VM מ-</a:t>
-            </a:r>
-            <a:r>
               <a:rPr b="1"/>
-              <a:t>kali.org</a:t>
-            </a:r>
-          </a:p>
-          <a:p>
-            <a:pPr lvl="0" algn="r" rtl="1"/>
-            <a:r>
-              <a:rPr/>
-              <a:t>התקנת VMware Workstation Player</a:t>
-            </a:r>
-          </a:p>
-          <a:p>
-            <a:pPr lvl="0" algn="r" rtl="1"/>
-            <a:r>
-              <a:rPr/>
-              <a:t>Open ← קובץ ה-</a:t>
-            </a:r>
-            <a:r>
-              <a:rPr>
-                <a:latin typeface="Courier"/>
-              </a:rPr>
-              <a:t>.vmx</a:t>
-            </a:r>
-          </a:p>
-          <a:p>
-            <a:pPr lvl="0" algn="r" rtl="1"/>
-            <a:r>
-              <a:rPr/>
-              <a:t>הגדרות: 2GB RAM לפחות, 2 ליבות</a:t>
-            </a:r>
-          </a:p>
-          <a:p>
-            <a:pPr lvl="0" algn="r" rtl="1"/>
-            <a:r>
-              <a:rPr/>
-              <a:t>התחברות: </a:t>
-            </a:r>
-            <a:r>
-              <a:rPr>
-                <a:latin typeface="Courier"/>
-              </a:rPr>
-              <a:t>kali</a:t>
-            </a:r>
-            <a:r>
-              <a:rPr/>
-              <a:t> / </a:t>
-            </a:r>
-            <a:r>
-              <a:rPr>
-                <a:latin typeface="Courier"/>
-              </a:rPr>
-              <a:t>kali</a:t>
+              <a:t>Black Box</a:t>
+            </a:r>
+            <a:r>
+              <a:rPr/>
+              <a:t> — מידע מינימלי (תוקף חיצוני)</a:t>
+            </a:r>
+          </a:p>
+          <a:p>
+            <a:pPr lvl="0" algn="r" rtl="1"/>
+            <a:r>
+              <a:rPr b="1"/>
+              <a:t>White Box</a:t>
+            </a:r>
+            <a:r>
+              <a:rPr/>
+              <a:t> — גישה מלאה (קוד, פרטים)</a:t>
+            </a:r>
+          </a:p>
+          <a:p>
+            <a:pPr lvl="0" algn="r" rtl="1"/>
+            <a:r>
+              <a:rPr b="1"/>
+              <a:t>Grey Box</a:t>
+            </a:r>
+            <a:r>
+              <a:rPr/>
+              <a:t> — מידע חלקי (הנפוץ ביותר)</a:t>
+            </a:r>
+          </a:p>
+          <a:p>
+            <a:pPr lvl="0" algn="r" rtl="1"/>
+            <a:r>
+              <a:rPr/>
+              <a:t>Engagements: External · Internal · Web · Wireless · Social</a:t>
             </a:r>
           </a:p>
         </p:txBody>
@@ -3865,7 +4192,7 @@
             </a:pPr>
             <a:r>
               <a:rPr/>
-              <a:t>Kali Linux — סקירה</a:t>
+              <a:t>טרמינולוגיה — הנוסחה</a:t>
             </a:r>
           </a:p>
         </p:txBody>
@@ -3887,33 +4214,43 @@
           <a:p>
             <a:pPr lvl="0" algn="r" rtl="1"/>
             <a:r>
-              <a:rPr/>
-              <a:t>הפצת לינוקס (Debian) לבדיקות חדירה</a:t>
-            </a:r>
-          </a:p>
-          <a:p>
-            <a:pPr lvl="0" algn="r" rtl="1"/>
-            <a:r>
-              <a:rPr/>
-              <a:t>300+ כלי אבטחה מותקנים מראש</a:t>
-            </a:r>
-          </a:p>
-          <a:p>
-            <a:pPr lvl="0" algn="r" rtl="1"/>
-            <a:r>
               <a:rPr b="1"/>
-              <a:t>Terminal</a:t>
-            </a:r>
-            <a:r>
-              <a:rPr/>
-              <a:t> = סביבת העבודה המרכזית</a:t>
-            </a:r>
-          </a:p>
-          <a:p>
-            <a:pPr lvl="0" algn="r" rtl="1"/>
-            <a:r>
-              <a:rPr/>
-              <a:t>כלים מסודרים לפי שלבי התקיפה</a:t>
+              <a:t>Vulnerability</a:t>
+            </a:r>
+            <a:r>
+              <a:rPr/>
+              <a:t> — הפגם (מנעול פגום)</a:t>
+            </a:r>
+          </a:p>
+          <a:p>
+            <a:pPr lvl="0" algn="r" rtl="1"/>
+            <a:r>
+              <a:rPr b="1"/>
+              <a:t>Exploit</a:t>
+            </a:r>
+            <a:r>
+              <a:rPr/>
+              <a:t> — ניצול הפגם (שיטת הפריצה)</a:t>
+            </a:r>
+          </a:p>
+          <a:p>
+            <a:pPr lvl="0" algn="r" rtl="1"/>
+            <a:r>
+              <a:rPr b="1"/>
+              <a:t>Payload</a:t>
+            </a:r>
+            <a:r>
+              <a:rPr/>
+              <a:t> — מה שרץ אחרי (הפעולה בפנים)</a:t>
+            </a:r>
+          </a:p>
+          <a:p>
+            <a:pPr lvl="0" algn="r" rtl="1"/>
+            <a:r>
+              <a:rPr>
+                <a:latin typeface="Courier"/>
+              </a:rPr>
+              <a:t>Vulnerability + Exploit + Payload = גישה</a:t>
             </a:r>
           </a:p>
         </p:txBody>
@@ -3960,7 +4297,7 @@
             </a:pPr>
             <a:r>
               <a:rPr/>
-              <a:t>קטגוריות הכלים</a:t>
+              <a:t>חמשת שלבי ההאקינג האתי</a:t>
             </a:r>
           </a:p>
         </p:txBody>
@@ -3982,43 +4319,56 @@
           <a:p>
             <a:pPr lvl="0" algn="r" rtl="1"/>
             <a:r>
-              <a:rPr/>
-              <a:t>Information Gathering — nmap, Maltego</a:t>
-            </a:r>
-          </a:p>
-          <a:p>
-            <a:pPr lvl="0" algn="r" rtl="1"/>
-            <a:r>
-              <a:rPr/>
-              <a:t>Vulnerability Analysis — Nessus</a:t>
-            </a:r>
-          </a:p>
-          <a:p>
-            <a:pPr lvl="0" algn="r" rtl="1"/>
-            <a:r>
-              <a:rPr/>
-              <a:t>Web Application — Burp Suite</a:t>
-            </a:r>
-          </a:p>
-          <a:p>
-            <a:pPr lvl="0" algn="r" rtl="1"/>
-            <a:r>
-              <a:rPr/>
-              <a:t>Password Attacks — Hydra, John</a:t>
-            </a:r>
-          </a:p>
-          <a:p>
-            <a:pPr lvl="0" algn="r" rtl="1"/>
-            <a:r>
-              <a:rPr/>
-              <a:t>Exploitation — Metasploit</a:t>
-            </a:r>
-          </a:p>
-          <a:p>
-            <a:pPr lvl="0" algn="r" rtl="1"/>
-            <a:r>
-              <a:rPr/>
-              <a:t>Sniffing &amp; Spoofing — Wireshark</a:t>
+              <a:rPr b="1"/>
+              <a:t>1. Reconnaissance</a:t>
+            </a:r>
+            <a:r>
+              <a:rPr/>
+              <a:t> — איסוף מידע (פסיבי/אקטיבי)</a:t>
+            </a:r>
+          </a:p>
+          <a:p>
+            <a:pPr lvl="0" algn="r" rtl="1"/>
+            <a:r>
+              <a:rPr b="1"/>
+              <a:t>2. Scanning &amp; Enumeration</a:t>
+            </a:r>
+            <a:r>
+              <a:rPr/>
+              <a:t> — פורטים ושירותים</a:t>
+            </a:r>
+          </a:p>
+          <a:p>
+            <a:pPr lvl="0" algn="r" rtl="1"/>
+            <a:r>
+              <a:rPr b="1"/>
+              <a:t>3. Gaining Access</a:t>
+            </a:r>
+            <a:r>
+              <a:rPr/>
+              <a:t> — ניצול חולשה</a:t>
+            </a:r>
+          </a:p>
+          <a:p>
+            <a:pPr lvl="0" algn="r" rtl="1"/>
+            <a:r>
+              <a:rPr b="1"/>
+              <a:t>4. Maintaining Access</a:t>
+            </a:r>
+            <a:r>
+              <a:rPr/>
+              <a:t> — שמירת גישה</a:t>
+            </a:r>
+          </a:p>
+          <a:p>
+            <a:pPr lvl="0" algn="r" rtl="1"/>
+            <a:r>
+              <a:rPr b="1"/>
+              <a:t>5. Covering Tracks</a:t>
+            </a:r>
+            <a:r>
+              <a:rPr/>
+              <a:t> — טשטוש עקבות</a:t>
             </a:r>
           </a:p>
         </p:txBody>
@@ -4065,7 +4415,7 @@
             </a:pPr>
             <a:r>
               <a:rPr/>
-              <a:t>מיומנויות נדרשות</a:t>
+              <a:t>היבטים משפטיים — לפני כל בדיקה</a:t>
             </a:r>
           </a:p>
         </p:txBody>
@@ -4088,40 +4438,44 @@
             <a:pPr lvl="0" algn="r" rtl="1"/>
             <a:r>
               <a:rPr b="1"/>
-              <a:t>Linux</a:t>
-            </a:r>
-            <a:r>
-              <a:rPr/>
-              <a:t> — שורת פקודה</a:t>
+              <a:t>Scope</a:t>
+            </a:r>
+            <a:r>
+              <a:rPr/>
+              <a:t> — מה מותר לתקוף</a:t>
             </a:r>
           </a:p>
           <a:p>
             <a:pPr lvl="0" algn="r" rtl="1"/>
             <a:r>
               <a:rPr b="1"/>
-              <a:t>רשתות (Networking)</a:t>
-            </a:r>
-            <a:r>
-              <a:rPr/>
-              <a:t> — OSI, TCP/UDP (מודול 3)</a:t>
+              <a:t>RoE</a:t>
+            </a:r>
+            <a:r>
+              <a:rPr/>
+              <a:t> — כללי ההתקשרות</a:t>
             </a:r>
           </a:p>
           <a:p>
             <a:pPr lvl="0" algn="r" rtl="1"/>
             <a:r>
               <a:rPr b="1"/>
-              <a:t>סקריפטינג</a:t>
-            </a:r>
-            <a:r>
-              <a:rPr/>
-              <a:t> — Bash, Python (מודול 4)</a:t>
-            </a:r>
-          </a:p>
-          <a:p>
-            <a:pPr lvl="0" algn="r" rtl="1"/>
-            <a:r>
-              <a:rPr/>
-              <a:t>הקורס מלמד הכל בהדרגה</a:t>
+              <a:t>NDA</a:t>
+            </a:r>
+            <a:r>
+              <a:rPr/>
+              <a:t> — הסכם סודיות</a:t>
+            </a:r>
+          </a:p>
+          <a:p>
+            <a:pPr lvl="0" algn="r" rtl="1"/>
+            <a:r>
+              <a:rPr b="1"/>
+              <a:t>מכתב הרשאה</a:t>
+            </a:r>
+            <a:r>
+              <a:rPr/>
+              <a:t> — הוכחת חוקיות</a:t>
             </a:r>
           </a:p>
         </p:txBody>

</xml_diff>

<commit_message>
Module 1: add story-driven intro (famous hacks/worms) to hook students
- New opening section: real-world stories (Morris Worm, ILOVEYOU, Stuxnet,
  WannaCry, Mirai, Equifax, Kevin Mitnick), each linked to a course module
- Aspirational hook: bug bounties, job demand, zero-to-pentester
- Added matching intro slides to the deck
- Rebuilt Module 1 artifacts (material 13p, deck 15 slides)

Verified structure audit across all 9 modules: all files present, RTL balanced,
section numbers and cross-links correct.

Co-Authored-By: Claude Opus 4.8 <noreply@anthropic.com>
Claude-Session: https://claude.ai/code/session_01Ghjnb4wipnzRi4CSLijMVc
</commit_message>
<xml_diff>
--- a/dist/slides-pptx/01-intro-lab-methodology.pptx
+++ b/dist/slides-pptx/01-intro-lab-methodology.pptx
@@ -18,6 +18,8 @@
     <p:sldId id="266" r:id="rId12"/>
     <p:sldId id="267" r:id="rId13"/>
     <p:sldId id="268" r:id="rId14"/>
+    <p:sldId id="269" r:id="rId15"/>
+    <p:sldId id="270" r:id="rId16"/>
   </p:sldIdLst>
   <p:sldSz cx="9144000" cy="5143500" type="screen16x9"/>
   <p:notesSz cx="6858000" cy="9144000"/>
@@ -3223,7 +3225,7 @@
             </a:pPr>
             <a:r>
               <a:rPr/>
-              <a:t>הקמת המעבדה</a:t>
+              <a:t>חמשת שלבי ההאקינג האתי</a:t>
             </a:r>
           </a:p>
         </p:txBody>
@@ -3246,56 +3248,55 @@
             <a:pPr lvl="0" algn="r" rtl="1"/>
             <a:r>
               <a:rPr b="1"/>
-              <a:t>Hypervisor</a:t>
-            </a:r>
-            <a:r>
-              <a:rPr/>
-              <a:t> — VMware / VirtualBox (חינמי)</a:t>
+              <a:t>1. Reconnaissance</a:t>
+            </a:r>
+            <a:r>
+              <a:rPr/>
+              <a:t> — איסוף מידע (פסיבי/אקטיבי)</a:t>
             </a:r>
           </a:p>
           <a:p>
             <a:pPr lvl="0" algn="r" rtl="1"/>
             <a:r>
               <a:rPr b="1"/>
-              <a:t>תוקף</a:t>
-            </a:r>
-            <a:r>
-              <a:rPr/>
-              <a:t> — Kali Linux · </a:t>
-            </a:r>
+              <a:t>2. Scanning &amp; Enumeration</a:t>
+            </a:r>
+            <a:r>
+              <a:rPr/>
+              <a:t> — פורטים ושירותים</a:t>
+            </a:r>
+          </a:p>
+          <a:p>
+            <a:pPr lvl="0" algn="r" rtl="1"/>
             <a:r>
               <a:rPr b="1"/>
-              <a:t>מטרות</a:t>
-            </a:r>
-            <a:r>
-              <a:rPr/>
-              <a:t> — Metasploitable, Kioptrix</a:t>
-            </a:r>
-          </a:p>
-          <a:p>
-            <a:pPr lvl="0" algn="r" rtl="1"/>
-            <a:r>
-              <a:rPr/>
-              <a:t>רשת: </a:t>
-            </a:r>
+              <a:t>3. Gaining Access</a:t>
+            </a:r>
+            <a:r>
+              <a:rPr/>
+              <a:t> — ניצול חולשה</a:t>
+            </a:r>
+          </a:p>
+          <a:p>
+            <a:pPr lvl="0" algn="r" rtl="1"/>
             <a:r>
               <a:rPr b="1"/>
-              <a:t>NAT / Host-Only</a:t>
-            </a:r>
-            <a:r>
-              <a:rPr/>
-              <a:t> (לא Bridged!) 🔒</a:t>
+              <a:t>4. Maintaining Access</a:t>
+            </a:r>
+            <a:r>
+              <a:rPr/>
+              <a:t> — שמירת גישה</a:t>
             </a:r>
           </a:p>
           <a:p>
             <a:pPr lvl="0" algn="r" rtl="1"/>
             <a:r>
               <a:rPr b="1"/>
-              <a:t>Snapshot</a:t>
-            </a:r>
-            <a:r>
-              <a:rPr/>
-              <a:t> נקי מיד אחרי התקנה</a:t>
+              <a:t>5. Covering Tracks</a:t>
+            </a:r>
+            <a:r>
+              <a:rPr/>
+              <a:t> — טשטוש עקבות</a:t>
             </a:r>
           </a:p>
         </p:txBody>
@@ -3342,7 +3343,7 @@
             </a:pPr>
             <a:r>
               <a:rPr/>
-              <a:t>Kali Linux — סקירה</a:t>
+              <a:t>היבטים משפטיים — לפני כל בדיקה</a:t>
             </a:r>
           </a:p>
         </p:txBody>
@@ -3364,49 +3365,45 @@
           <a:p>
             <a:pPr lvl="0" algn="r" rtl="1"/>
             <a:r>
-              <a:rPr/>
-              <a:t>הפצת Debian לבדיקות חדירה, 600+ כלים</a:t>
-            </a:r>
-          </a:p>
-          <a:p>
-            <a:pPr lvl="0" algn="r" rtl="1"/>
-            <a:r>
-              <a:rPr/>
-              <a:t>עדכון: </a:t>
-            </a:r>
-            <a:r>
-              <a:rPr>
-                <a:latin typeface="Courier"/>
-              </a:rPr>
-              <a:t>sudo apt update &amp;&amp; sudo apt full-upgrade -y</a:t>
-            </a:r>
-          </a:p>
-          <a:p>
-            <a:pPr lvl="0" algn="r" rtl="1"/>
-            <a:r>
               <a:rPr b="1"/>
-              <a:t>Terminal</a:t>
-            </a:r>
-            <a:r>
-              <a:rPr/>
-              <a:t> = סביבת העבודה המרכזית</a:t>
-            </a:r>
-          </a:p>
-          <a:p>
-            <a:pPr lvl="0" algn="r" rtl="1"/>
-            <a:r>
-              <a:rPr/>
-              <a:t>wordlists ב-</a:t>
-            </a:r>
-            <a:r>
-              <a:rPr>
-                <a:latin typeface="Courier"/>
-              </a:rPr>
-              <a:t>/usr/share/wordlists</a:t>
-            </a:r>
-            <a:r>
-              <a:rPr/>
-              <a:t> (rockyou)</a:t>
+              <a:t>Scope</a:t>
+            </a:r>
+            <a:r>
+              <a:rPr/>
+              <a:t> — מה מותר לתקוף</a:t>
+            </a:r>
+          </a:p>
+          <a:p>
+            <a:pPr lvl="0" algn="r" rtl="1"/>
+            <a:r>
+              <a:rPr b="1"/>
+              <a:t>RoE</a:t>
+            </a:r>
+            <a:r>
+              <a:rPr/>
+              <a:t> — כללי ההתקשרות</a:t>
+            </a:r>
+          </a:p>
+          <a:p>
+            <a:pPr lvl="0" algn="r" rtl="1"/>
+            <a:r>
+              <a:rPr b="1"/>
+              <a:t>NDA</a:t>
+            </a:r>
+            <a:r>
+              <a:rPr/>
+              <a:t> — הסכם סודיות</a:t>
+            </a:r>
+          </a:p>
+          <a:p>
+            <a:pPr lvl="0" algn="r" rtl="1"/>
+            <a:r>
+              <a:rPr b="1"/>
+              <a:t>מכתב הרשאה</a:t>
+            </a:r>
+            <a:r>
+              <a:rPr/>
+              <a:t> — הוכחת חוקיות</a:t>
             </a:r>
           </a:p>
         </p:txBody>
@@ -3453,7 +3450,7 @@
             </a:pPr>
             <a:r>
               <a:rPr/>
-              <a:t>קטגוריות הכלים</a:t>
+              <a:t>הקמת המעבדה</a:t>
             </a:r>
           </a:p>
         </p:txBody>
@@ -3475,36 +3472,57 @@
           <a:p>
             <a:pPr lvl="0" algn="r" rtl="1"/>
             <a:r>
-              <a:rPr/>
-              <a:t>Information Gathering — nmap</a:t>
-            </a:r>
-          </a:p>
-          <a:p>
-            <a:pPr lvl="0" algn="r" rtl="1"/>
-            <a:r>
-              <a:rPr/>
-              <a:t>Vulnerability Analysis — nikto, Nessus</a:t>
-            </a:r>
-          </a:p>
-          <a:p>
-            <a:pPr lvl="0" algn="r" rtl="1"/>
-            <a:r>
-              <a:rPr/>
-              <a:t>Web — Burp Suite · Passwords — hydra</a:t>
-            </a:r>
-          </a:p>
-          <a:p>
-            <a:pPr lvl="0" algn="r" rtl="1"/>
-            <a:r>
-              <a:rPr/>
-              <a:t>Exploitation — Metasploit</a:t>
-            </a:r>
-          </a:p>
-          <a:p>
-            <a:pPr lvl="0" algn="r" rtl="1"/>
-            <a:r>
-              <a:rPr/>
-              <a:t>Sniffing — Wireshark · Post-Exp — mimikatz</a:t>
+              <a:rPr b="1"/>
+              <a:t>Hypervisor</a:t>
+            </a:r>
+            <a:r>
+              <a:rPr/>
+              <a:t> — VMware / VirtualBox (חינמי)</a:t>
+            </a:r>
+          </a:p>
+          <a:p>
+            <a:pPr lvl="0" algn="r" rtl="1"/>
+            <a:r>
+              <a:rPr b="1"/>
+              <a:t>תוקף</a:t>
+            </a:r>
+            <a:r>
+              <a:rPr/>
+              <a:t> — Kali Linux · </a:t>
+            </a:r>
+            <a:r>
+              <a:rPr b="1"/>
+              <a:t>מטרות</a:t>
+            </a:r>
+            <a:r>
+              <a:rPr/>
+              <a:t> — Metasploitable, Kioptrix</a:t>
+            </a:r>
+          </a:p>
+          <a:p>
+            <a:pPr lvl="0" algn="r" rtl="1"/>
+            <a:r>
+              <a:rPr/>
+              <a:t>רשת: </a:t>
+            </a:r>
+            <a:r>
+              <a:rPr b="1"/>
+              <a:t>NAT / Host-Only</a:t>
+            </a:r>
+            <a:r>
+              <a:rPr/>
+              <a:t> (לא Bridged!) 🔒</a:t>
+            </a:r>
+          </a:p>
+          <a:p>
+            <a:pPr lvl="0" algn="r" rtl="1"/>
+            <a:r>
+              <a:rPr b="1"/>
+              <a:t>Snapshot</a:t>
+            </a:r>
+            <a:r>
+              <a:rPr/>
+              <a:t> נקי מיד אחרי התקנה</a:t>
             </a:r>
           </a:p>
         </p:txBody>
@@ -3551,6 +3569,215 @@
             </a:pPr>
             <a:r>
               <a:rPr/>
+              <a:t>Kali Linux — סקירה</a:t>
+            </a:r>
+          </a:p>
+        </p:txBody>
+      </p:sp>
+      <p:sp>
+        <p:nvSpPr>
+          <p:cNvPr id="3" name="Content Placeholder 2"/>
+          <p:cNvSpPr>
+            <a:spLocks noGrp="1"/>
+          </p:cNvSpPr>
+          <p:nvPr>
+            <p:ph idx="1"/>
+          </p:nvPr>
+        </p:nvSpPr>
+        <p:spPr/>
+        <p:txBody>
+          <a:bodyPr/>
+          <a:lstStyle/>
+          <a:p>
+            <a:pPr lvl="0" algn="r" rtl="1"/>
+            <a:r>
+              <a:rPr/>
+              <a:t>הפצת Debian לבדיקות חדירה, 600+ כלים</a:t>
+            </a:r>
+          </a:p>
+          <a:p>
+            <a:pPr lvl="0" algn="r" rtl="1"/>
+            <a:r>
+              <a:rPr/>
+              <a:t>עדכון: </a:t>
+            </a:r>
+            <a:r>
+              <a:rPr>
+                <a:latin typeface="Courier"/>
+              </a:rPr>
+              <a:t>sudo apt update &amp;&amp; sudo apt full-upgrade -y</a:t>
+            </a:r>
+          </a:p>
+          <a:p>
+            <a:pPr lvl="0" algn="r" rtl="1"/>
+            <a:r>
+              <a:rPr b="1"/>
+              <a:t>Terminal</a:t>
+            </a:r>
+            <a:r>
+              <a:rPr/>
+              <a:t> = סביבת העבודה המרכזית</a:t>
+            </a:r>
+          </a:p>
+          <a:p>
+            <a:pPr lvl="0" algn="r" rtl="1"/>
+            <a:r>
+              <a:rPr/>
+              <a:t>wordlists ב-</a:t>
+            </a:r>
+            <a:r>
+              <a:rPr>
+                <a:latin typeface="Courier"/>
+              </a:rPr>
+              <a:t>/usr/share/wordlists</a:t>
+            </a:r>
+            <a:r>
+              <a:rPr/>
+              <a:t> (rockyou)</a:t>
+            </a:r>
+          </a:p>
+        </p:txBody>
+      </p:sp>
+    </p:spTree>
+  </p:cSld>
+</p:sld>
+</file>
+
+<file path=ppt/slides/slide14.xml><?xml version="1.0" encoding="utf-8"?>
+<p:sld xmlns:a="http://schemas.openxmlformats.org/drawingml/2006/main" xmlns:r="http://schemas.openxmlformats.org/officeDocument/2006/relationships" xmlns:p="http://schemas.openxmlformats.org/presentationml/2006/main">
+  <p:cSld>
+    <p:spTree>
+      <p:nvGrpSpPr>
+        <p:cNvPr id="1" name=""/>
+        <p:cNvGrpSpPr/>
+        <p:nvPr/>
+      </p:nvGrpSpPr>
+      <p:grpSpPr>
+        <a:xfrm>
+          <a:off x="0" y="0"/>
+          <a:ext cx="0" cy="0"/>
+          <a:chOff x="0" y="0"/>
+          <a:chExt cx="0" cy="0"/>
+        </a:xfrm>
+      </p:grpSpPr>
+      <p:sp>
+        <p:nvSpPr>
+          <p:cNvPr id="2" name="Title 1"/>
+          <p:cNvSpPr>
+            <a:spLocks noGrp="1"/>
+          </p:cNvSpPr>
+          <p:nvPr>
+            <p:ph type="title"/>
+          </p:nvPr>
+        </p:nvSpPr>
+        <p:spPr/>
+        <p:txBody>
+          <a:bodyPr/>
+          <a:lstStyle/>
+          <a:p>
+            <a:pPr marL="0" lvl="0" indent="0" algn="r" rtl="1">
+              <a:buNone/>
+            </a:pPr>
+            <a:r>
+              <a:rPr/>
+              <a:t>קטגוריות הכלים</a:t>
+            </a:r>
+          </a:p>
+        </p:txBody>
+      </p:sp>
+      <p:sp>
+        <p:nvSpPr>
+          <p:cNvPr id="3" name="Content Placeholder 2"/>
+          <p:cNvSpPr>
+            <a:spLocks noGrp="1"/>
+          </p:cNvSpPr>
+          <p:nvPr>
+            <p:ph idx="1"/>
+          </p:nvPr>
+        </p:nvSpPr>
+        <p:spPr/>
+        <p:txBody>
+          <a:bodyPr/>
+          <a:lstStyle/>
+          <a:p>
+            <a:pPr lvl="0" algn="r" rtl="1"/>
+            <a:r>
+              <a:rPr/>
+              <a:t>Information Gathering — nmap</a:t>
+            </a:r>
+          </a:p>
+          <a:p>
+            <a:pPr lvl="0" algn="r" rtl="1"/>
+            <a:r>
+              <a:rPr/>
+              <a:t>Vulnerability Analysis — nikto, Nessus</a:t>
+            </a:r>
+          </a:p>
+          <a:p>
+            <a:pPr lvl="0" algn="r" rtl="1"/>
+            <a:r>
+              <a:rPr/>
+              <a:t>Web — Burp Suite · Passwords — hydra</a:t>
+            </a:r>
+          </a:p>
+          <a:p>
+            <a:pPr lvl="0" algn="r" rtl="1"/>
+            <a:r>
+              <a:rPr/>
+              <a:t>Exploitation — Metasploit</a:t>
+            </a:r>
+          </a:p>
+          <a:p>
+            <a:pPr lvl="0" algn="r" rtl="1"/>
+            <a:r>
+              <a:rPr/>
+              <a:t>Sniffing — Wireshark · Post-Exp — mimikatz</a:t>
+            </a:r>
+          </a:p>
+        </p:txBody>
+      </p:sp>
+    </p:spTree>
+  </p:cSld>
+</p:sld>
+</file>
+
+<file path=ppt/slides/slide15.xml><?xml version="1.0" encoding="utf-8"?>
+<p:sld xmlns:a="http://schemas.openxmlformats.org/drawingml/2006/main" xmlns:r="http://schemas.openxmlformats.org/officeDocument/2006/relationships" xmlns:p="http://schemas.openxmlformats.org/presentationml/2006/main">
+  <p:cSld>
+    <p:spTree>
+      <p:nvGrpSpPr>
+        <p:cNvPr id="1" name=""/>
+        <p:cNvGrpSpPr/>
+        <p:nvPr/>
+      </p:nvGrpSpPr>
+      <p:grpSpPr>
+        <a:xfrm>
+          <a:off x="0" y="0"/>
+          <a:ext cx="0" cy="0"/>
+          <a:chOff x="0" y="0"/>
+          <a:chExt cx="0" cy="0"/>
+        </a:xfrm>
+      </p:grpSpPr>
+      <p:sp>
+        <p:nvSpPr>
+          <p:cNvPr id="2" name="Title 1"/>
+          <p:cNvSpPr>
+            <a:spLocks noGrp="1"/>
+          </p:cNvSpPr>
+          <p:nvPr>
+            <p:ph type="title"/>
+          </p:nvPr>
+        </p:nvSpPr>
+        <p:spPr/>
+        <p:txBody>
+          <a:bodyPr/>
+          <a:lstStyle/>
+          <a:p>
+            <a:pPr marL="0" lvl="0" indent="0" algn="r" rtl="1">
+              <a:buNone/>
+            </a:pPr>
+            <a:r>
+              <a:rPr/>
               <a:t>סיכום מודול 1</a:t>
             </a:r>
           </a:p>
@@ -3768,7 +3995,7 @@
             </a:pPr>
             <a:r>
               <a:rPr/>
-              <a:t>מהו האקינג אתי?</a:t>
+              <a:t>🎬 סיפורים שישנו את העולם</a:t>
             </a:r>
           </a:p>
         </p:txBody>
@@ -3790,53 +4017,62 @@
           <a:p>
             <a:pPr lvl="0" algn="r" rtl="1"/>
             <a:r>
-              <a:rPr/>
-              <a:t>בדיקה </a:t>
-            </a:r>
-            <a:r>
               <a:rPr b="1"/>
-              <a:t>מורשית</a:t>
-            </a:r>
-            <a:r>
-              <a:rPr/>
-              <a:t> למציאת חולשות לפני התוקף</a:t>
-            </a:r>
-          </a:p>
-          <a:p>
-            <a:pPr lvl="0" algn="r" rtl="1"/>
-            <a:r>
-              <a:rPr/>
-              <a:t>אותם כלים של התוקף — אך בהרשאה ולמטרת הגנה</a:t>
-            </a:r>
-          </a:p>
-          <a:p>
-            <a:pPr lvl="0" algn="r" rtl="1"/>
-            <a:r>
-              <a:rPr/>
-              <a:t>ההבדל: </a:t>
-            </a:r>
+              <a:t>תולעת מוריס (1988)</a:t>
+            </a:r>
+            <a:r>
+              <a:rPr/>
+              <a:t> — שיתקה 10% מהאינטרנט</a:t>
+            </a:r>
+          </a:p>
+          <a:p>
+            <a:pPr lvl="0" algn="r" rtl="1"/>
             <a:r>
               <a:rPr b="1"/>
-              <a:t>הרשאה</a:t>
-            </a:r>
-            <a:r>
-              <a:rPr/>
-              <a:t> + </a:t>
-            </a:r>
+              <a:t>ILOVEYOU (2000)</a:t>
+            </a:r>
+            <a:r>
+              <a:rPr/>
+              <a:t> — 50M מחשבים ב-10 ימים</a:t>
+            </a:r>
+          </a:p>
+          <a:p>
+            <a:pPr lvl="0" algn="r" rtl="1"/>
             <a:r>
               <a:rPr b="1"/>
-              <a:t>כוונה</a:t>
-            </a:r>
-            <a:r>
-              <a:rPr/>
-              <a:t>, לא הכלים</a:t>
-            </a:r>
-          </a:p>
-          <a:p>
-            <a:pPr lvl="0" algn="r" rtl="1"/>
-            <a:r>
-              <a:rPr/>
-              <a:t>⚠️ ללא אישור בכתב = עבירה פלילית</a:t>
+              <a:t>Stuxnet (2010)</a:t>
+            </a:r>
+            <a:r>
+              <a:rPr/>
+              <a:t> — קוד שהרס צנטריפוגות</a:t>
+            </a:r>
+          </a:p>
+          <a:p>
+            <a:pPr lvl="0" algn="r" rtl="1"/>
+            <a:r>
+              <a:rPr b="1"/>
+              <a:t>WannaCry (2017)</a:t>
+            </a:r>
+            <a:r>
+              <a:rPr/>
+              <a:t> — שיתקה בתי חולים (SMB!)</a:t>
+            </a:r>
+          </a:p>
+          <a:p>
+            <a:pPr lvl="0" algn="r" rtl="1"/>
+            <a:r>
+              <a:rPr b="1"/>
+              <a:t>Mirai (2016)</a:t>
+            </a:r>
+            <a:r>
+              <a:rPr/>
+              <a:t> — צבא מצלמות עם </a:t>
+            </a:r>
+            <a:r>
+              <a:rPr>
+                <a:latin typeface="Courier"/>
+              </a:rPr>
+              <a:t>admin/admin</a:t>
             </a:r>
           </a:p>
         </p:txBody>
@@ -3883,7 +4119,7 @@
             </a:pPr>
             <a:r>
               <a:rPr/>
-              <a:t>CIA Triad — שלושת עמודי התווך</a:t>
+              <a:t>בכל סיפור — האקר אתי היה מונע את האסון</a:t>
             </a:r>
           </a:p>
         </p:txBody>
@@ -3905,41 +4141,41 @@
           <a:p>
             <a:pPr lvl="0" algn="r" rtl="1"/>
             <a:r>
+              <a:rPr/>
+              <a:t>Bug Bounty: Google/Facebook </a:t>
+            </a:r>
+            <a:r>
               <a:rPr b="1"/>
-              <a:t>Confidentiality</a:t>
-            </a:r>
-            <a:r>
-              <a:rPr/>
-              <a:t> (סודיות) — רק מורשים רואים</a:t>
+              <a:t>משלמות</a:t>
+            </a:r>
+            <a:r>
+              <a:rPr/>
+              <a:t> על חולשות</a:t>
+            </a:r>
+          </a:p>
+          <a:p>
+            <a:pPr lvl="0" algn="r" rtl="1"/>
+            <a:r>
+              <a:rPr/>
+              <a:t>מחסור עולמי במיליוני אנשי אבטחה</a:t>
+            </a:r>
+          </a:p>
+          <a:p>
+            <a:pPr lvl="0" algn="r" rtl="1"/>
+            <a:r>
+              <a:rPr/>
+              <a:t>אתם מתחילים מאפס → בדיקת חדירות מלאה 🚀</a:t>
             </a:r>
           </a:p>
           <a:p>
             <a:pPr lvl="0" algn="r" rtl="1"/>
             <a:r>
               <a:rPr b="1"/>
-              <a:t>Integrity</a:t>
-            </a:r>
-            <a:r>
-              <a:rPr/>
-              <a:t> (שלמות) — המידע לא שונה</a:t>
-            </a:r>
-          </a:p>
-          <a:p>
-            <a:pPr lvl="0" algn="r" rtl="1"/>
-            <a:r>
-              <a:rPr b="1"/>
-              <a:t>Availability</a:t>
-            </a:r>
-            <a:r>
-              <a:rPr/>
-              <a:t> (זמינות) — המערכת זמינה</a:t>
-            </a:r>
-          </a:p>
-          <a:p>
-            <a:pPr lvl="0" algn="r" rtl="1"/>
-            <a:r>
-              <a:rPr/>
-              <a:t>כל ממצא מסווג לפי העיקרון שנפגע</a:t>
+              <a:t>זה</a:t>
+            </a:r>
+            <a:r>
+              <a:rPr/>
+              <a:t> מה שנלמד לעשות</a:t>
             </a:r>
           </a:p>
         </p:txBody>
@@ -3986,7 +4222,7 @@
             </a:pPr>
             <a:r>
               <a:rPr/>
-              <a:t>סוגי האקרים (Threat Actors)</a:t>
+              <a:t>מהו האקינג אתי?</a:t>
             </a:r>
           </a:p>
         </p:txBody>
@@ -4008,41 +4244,53 @@
           <a:p>
             <a:pPr lvl="0" algn="r" rtl="1"/>
             <a:r>
+              <a:rPr/>
+              <a:t>בדיקה </a:t>
+            </a:r>
+            <a:r>
               <a:rPr b="1"/>
-              <a:t>White Hat</a:t>
-            </a:r>
-            <a:r>
-              <a:rPr/>
-              <a:t> — אתי, בהרשאה (זה אנחנו)</a:t>
-            </a:r>
-          </a:p>
-          <a:p>
-            <a:pPr lvl="0" algn="r" rtl="1"/>
+              <a:t>מורשית</a:t>
+            </a:r>
+            <a:r>
+              <a:rPr/>
+              <a:t> למציאת חולשות לפני התוקף</a:t>
+            </a:r>
+          </a:p>
+          <a:p>
+            <a:pPr lvl="0" algn="r" rtl="1"/>
+            <a:r>
+              <a:rPr/>
+              <a:t>אותם כלים של התוקף — אך בהרשאה ולמטרת הגנה</a:t>
+            </a:r>
+          </a:p>
+          <a:p>
+            <a:pPr lvl="0" algn="r" rtl="1"/>
+            <a:r>
+              <a:rPr/>
+              <a:t>ההבדל: </a:t>
+            </a:r>
             <a:r>
               <a:rPr b="1"/>
-              <a:t>Black Hat</a:t>
-            </a:r>
-            <a:r>
-              <a:rPr/>
-              <a:t> — זדוני, ללא הרשאה</a:t>
-            </a:r>
-          </a:p>
-          <a:p>
-            <a:pPr lvl="0" algn="r" rtl="1"/>
+              <a:t>הרשאה</a:t>
+            </a:r>
+            <a:r>
+              <a:rPr/>
+              <a:t> + </a:t>
+            </a:r>
             <a:r>
               <a:rPr b="1"/>
-              <a:t>Grey Hat</a:t>
-            </a:r>
-            <a:r>
-              <a:rPr/>
-              <a:t> — ללא הרשאה, ללא זדון</a:t>
-            </a:r>
-          </a:p>
-          <a:p>
-            <a:pPr lvl="0" algn="r" rtl="1"/>
-            <a:r>
-              <a:rPr b="1"/>
-              <a:t>Script Kiddie · Hacktivist · APT · Insider</a:t>
+              <a:t>כוונה</a:t>
+            </a:r>
+            <a:r>
+              <a:rPr/>
+              <a:t>, לא הכלים</a:t>
+            </a:r>
+          </a:p>
+          <a:p>
+            <a:pPr lvl="0" algn="r" rtl="1"/>
+            <a:r>
+              <a:rPr/>
+              <a:t>⚠️ ללא אישור בכתב = עבירה פלילית</a:t>
             </a:r>
           </a:p>
         </p:txBody>
@@ -4089,7 +4337,7 @@
             </a:pPr>
             <a:r>
               <a:rPr/>
-              <a:t>סוגי בדיקות חדירה</a:t>
+              <a:t>CIA Triad — שלושת עמודי התווך</a:t>
             </a:r>
           </a:p>
         </p:txBody>
@@ -4112,40 +4360,40 @@
             <a:pPr lvl="0" algn="r" rtl="1"/>
             <a:r>
               <a:rPr b="1"/>
-              <a:t>Black Box</a:t>
-            </a:r>
-            <a:r>
-              <a:rPr/>
-              <a:t> — מידע מינימלי (תוקף חיצוני)</a:t>
+              <a:t>Confidentiality</a:t>
+            </a:r>
+            <a:r>
+              <a:rPr/>
+              <a:t> (סודיות) — רק מורשים רואים</a:t>
             </a:r>
           </a:p>
           <a:p>
             <a:pPr lvl="0" algn="r" rtl="1"/>
             <a:r>
               <a:rPr b="1"/>
-              <a:t>White Box</a:t>
-            </a:r>
-            <a:r>
-              <a:rPr/>
-              <a:t> — גישה מלאה (קוד, פרטים)</a:t>
+              <a:t>Integrity</a:t>
+            </a:r>
+            <a:r>
+              <a:rPr/>
+              <a:t> (שלמות) — המידע לא שונה</a:t>
             </a:r>
           </a:p>
           <a:p>
             <a:pPr lvl="0" algn="r" rtl="1"/>
             <a:r>
               <a:rPr b="1"/>
-              <a:t>Grey Box</a:t>
-            </a:r>
-            <a:r>
-              <a:rPr/>
-              <a:t> — מידע חלקי (הנפוץ ביותר)</a:t>
-            </a:r>
-          </a:p>
-          <a:p>
-            <a:pPr lvl="0" algn="r" rtl="1"/>
-            <a:r>
-              <a:rPr/>
-              <a:t>Engagements: External · Internal · Web · Wireless · Social</a:t>
+              <a:t>Availability</a:t>
+            </a:r>
+            <a:r>
+              <a:rPr/>
+              <a:t> (זמינות) — המערכת זמינה</a:t>
+            </a:r>
+          </a:p>
+          <a:p>
+            <a:pPr lvl="0" algn="r" rtl="1"/>
+            <a:r>
+              <a:rPr/>
+              <a:t>כל ממצא מסווג לפי העיקרון שנפגע</a:t>
             </a:r>
           </a:p>
         </p:txBody>
@@ -4192,7 +4440,7 @@
             </a:pPr>
             <a:r>
               <a:rPr/>
-              <a:t>טרמינולוגיה — הנוסחה</a:t>
+              <a:t>סוגי האקרים (Threat Actors)</a:t>
             </a:r>
           </a:p>
         </p:txBody>
@@ -4215,42 +4463,40 @@
             <a:pPr lvl="0" algn="r" rtl="1"/>
             <a:r>
               <a:rPr b="1"/>
-              <a:t>Vulnerability</a:t>
-            </a:r>
-            <a:r>
-              <a:rPr/>
-              <a:t> — הפגם (מנעול פגום)</a:t>
+              <a:t>White Hat</a:t>
+            </a:r>
+            <a:r>
+              <a:rPr/>
+              <a:t> — אתי, בהרשאה (זה אנחנו)</a:t>
             </a:r>
           </a:p>
           <a:p>
             <a:pPr lvl="0" algn="r" rtl="1"/>
             <a:r>
               <a:rPr b="1"/>
-              <a:t>Exploit</a:t>
-            </a:r>
-            <a:r>
-              <a:rPr/>
-              <a:t> — ניצול הפגם (שיטת הפריצה)</a:t>
+              <a:t>Black Hat</a:t>
+            </a:r>
+            <a:r>
+              <a:rPr/>
+              <a:t> — זדוני, ללא הרשאה</a:t>
             </a:r>
           </a:p>
           <a:p>
             <a:pPr lvl="0" algn="r" rtl="1"/>
             <a:r>
               <a:rPr b="1"/>
-              <a:t>Payload</a:t>
-            </a:r>
-            <a:r>
-              <a:rPr/>
-              <a:t> — מה שרץ אחרי (הפעולה בפנים)</a:t>
-            </a:r>
-          </a:p>
-          <a:p>
-            <a:pPr lvl="0" algn="r" rtl="1"/>
-            <a:r>
-              <a:rPr>
-                <a:latin typeface="Courier"/>
-              </a:rPr>
-              <a:t>Vulnerability + Exploit + Payload = גישה</a:t>
+              <a:t>Grey Hat</a:t>
+            </a:r>
+            <a:r>
+              <a:rPr/>
+              <a:t> — ללא הרשאה, ללא זדון</a:t>
+            </a:r>
+          </a:p>
+          <a:p>
+            <a:pPr lvl="0" algn="r" rtl="1"/>
+            <a:r>
+              <a:rPr b="1"/>
+              <a:t>Script Kiddie · Hacktivist · APT · Insider</a:t>
             </a:r>
           </a:p>
         </p:txBody>
@@ -4297,7 +4543,7 @@
             </a:pPr>
             <a:r>
               <a:rPr/>
-              <a:t>חמשת שלבי ההאקינג האתי</a:t>
+              <a:t>סוגי בדיקות חדירה</a:t>
             </a:r>
           </a:p>
         </p:txBody>
@@ -4320,55 +4566,40 @@
             <a:pPr lvl="0" algn="r" rtl="1"/>
             <a:r>
               <a:rPr b="1"/>
-              <a:t>1. Reconnaissance</a:t>
-            </a:r>
-            <a:r>
-              <a:rPr/>
-              <a:t> — איסוף מידע (פסיבי/אקטיבי)</a:t>
+              <a:t>Black Box</a:t>
+            </a:r>
+            <a:r>
+              <a:rPr/>
+              <a:t> — מידע מינימלי (תוקף חיצוני)</a:t>
             </a:r>
           </a:p>
           <a:p>
             <a:pPr lvl="0" algn="r" rtl="1"/>
             <a:r>
               <a:rPr b="1"/>
-              <a:t>2. Scanning &amp; Enumeration</a:t>
-            </a:r>
-            <a:r>
-              <a:rPr/>
-              <a:t> — פורטים ושירותים</a:t>
+              <a:t>White Box</a:t>
+            </a:r>
+            <a:r>
+              <a:rPr/>
+              <a:t> — גישה מלאה (קוד, פרטים)</a:t>
             </a:r>
           </a:p>
           <a:p>
             <a:pPr lvl="0" algn="r" rtl="1"/>
             <a:r>
               <a:rPr b="1"/>
-              <a:t>3. Gaining Access</a:t>
-            </a:r>
-            <a:r>
-              <a:rPr/>
-              <a:t> — ניצול חולשה</a:t>
-            </a:r>
-          </a:p>
-          <a:p>
-            <a:pPr lvl="0" algn="r" rtl="1"/>
-            <a:r>
-              <a:rPr b="1"/>
-              <a:t>4. Maintaining Access</a:t>
-            </a:r>
-            <a:r>
-              <a:rPr/>
-              <a:t> — שמירת גישה</a:t>
-            </a:r>
-          </a:p>
-          <a:p>
-            <a:pPr lvl="0" algn="r" rtl="1"/>
-            <a:r>
-              <a:rPr b="1"/>
-              <a:t>5. Covering Tracks</a:t>
-            </a:r>
-            <a:r>
-              <a:rPr/>
-              <a:t> — טשטוש עקבות</a:t>
+              <a:t>Grey Box</a:t>
+            </a:r>
+            <a:r>
+              <a:rPr/>
+              <a:t> — מידע חלקי (הנפוץ ביותר)</a:t>
+            </a:r>
+          </a:p>
+          <a:p>
+            <a:pPr lvl="0" algn="r" rtl="1"/>
+            <a:r>
+              <a:rPr/>
+              <a:t>Engagements: External · Internal · Web · Wireless · Social</a:t>
             </a:r>
           </a:p>
         </p:txBody>
@@ -4415,7 +4646,7 @@
             </a:pPr>
             <a:r>
               <a:rPr/>
-              <a:t>היבטים משפטיים — לפני כל בדיקה</a:t>
+              <a:t>טרמינולוגיה — הנוסחה</a:t>
             </a:r>
           </a:p>
         </p:txBody>
@@ -4438,44 +4669,42 @@
             <a:pPr lvl="0" algn="r" rtl="1"/>
             <a:r>
               <a:rPr b="1"/>
-              <a:t>Scope</a:t>
-            </a:r>
-            <a:r>
-              <a:rPr/>
-              <a:t> — מה מותר לתקוף</a:t>
+              <a:t>Vulnerability</a:t>
+            </a:r>
+            <a:r>
+              <a:rPr/>
+              <a:t> — הפגם (מנעול פגום)</a:t>
             </a:r>
           </a:p>
           <a:p>
             <a:pPr lvl="0" algn="r" rtl="1"/>
             <a:r>
               <a:rPr b="1"/>
-              <a:t>RoE</a:t>
-            </a:r>
-            <a:r>
-              <a:rPr/>
-              <a:t> — כללי ההתקשרות</a:t>
+              <a:t>Exploit</a:t>
+            </a:r>
+            <a:r>
+              <a:rPr/>
+              <a:t> — ניצול הפגם (שיטת הפריצה)</a:t>
             </a:r>
           </a:p>
           <a:p>
             <a:pPr lvl="0" algn="r" rtl="1"/>
             <a:r>
               <a:rPr b="1"/>
-              <a:t>NDA</a:t>
-            </a:r>
-            <a:r>
-              <a:rPr/>
-              <a:t> — הסכם סודיות</a:t>
-            </a:r>
-          </a:p>
-          <a:p>
-            <a:pPr lvl="0" algn="r" rtl="1"/>
-            <a:r>
-              <a:rPr b="1"/>
-              <a:t>מכתב הרשאה</a:t>
-            </a:r>
-            <a:r>
-              <a:rPr/>
-              <a:t> — הוכחת חוקיות</a:t>
+              <a:t>Payload</a:t>
+            </a:r>
+            <a:r>
+              <a:rPr/>
+              <a:t> — מה שרץ אחרי (הפעולה בפנים)</a:t>
+            </a:r>
+          </a:p>
+          <a:p>
+            <a:pPr lvl="0" algn="r" rtl="1"/>
+            <a:r>
+              <a:rPr>
+                <a:latin typeface="Courier"/>
+              </a:rPr>
+              <a:t>Vulnerability + Exploit + Payload = גישה</a:t>
             </a:r>
           </a:p>
         </p:txBody>

</xml_diff>